<commit_message>
Update real event validation metrics and retrain metrics for improved model evaluation
- Updated the `real_event_validation_metrics.json` with new generated timestamps, adjusted thresholds, and recalibrated metrics including accuracy, recall, and F1 scores.
- Enhanced the `retrain_real_metrics.json` to reflect changes in the training dataset, including a new temporal split for training, validation, and testing. Updated threshold selection methodology and metrics.
- Modified ROC curve images to reflect updated model performance.
- Adjusted the training script to implement a 3-way temporal split for validation and testing, ensuring the F2 threshold is selected based on validation data.
- Added functionality to compare predictions from the new model against the old synthetic model in the validation scripts.
- Updated validation scripts to include definitions for control datasets and improved error handling for metrics extraction.
</commit_message>
<xml_diff>
--- a/Panel_Validation_Response.pptx
+++ b/Panel_Validation_Response.pptx
@@ -3165,13 +3165,13 @@
           </a:bodyPr>
           <a:lstStyle/>
           <a:p>
-            <a:pPr>
+            <a:pPr algn="l">
               <a:spcAft>
                 <a:spcPts val="200"/>
               </a:spcAft>
             </a:pPr>
             <a:r>
-              <a:rPr sz="900" b="1">
+              <a:rPr sz="900" b="1" i="0">
                 <a:solidFill>
                   <a:srgbClr val="0071E3"/>
                 </a:solidFill>
@@ -3181,8 +3181,13 @@
             </a:r>
           </a:p>
           <a:p>
-            <a:r>
-              <a:rPr sz="1050" i="1">
+            <a:pPr algn="l">
+              <a:spcAft>
+                <a:spcPts val="0"/>
+              </a:spcAft>
+            </a:pPr>
+            <a:r>
+              <a:rPr sz="1050" b="0" i="1">
                 <a:solidFill>
                   <a:srgbClr val="1D1D1F"/>
                 </a:solidFill>
@@ -3266,7 +3271,7 @@
                 </a:solidFill>
                 <a:latin typeface="Segoe UI"/>
               </a:rPr>
-              <a:t>Action taken to address the panel’s validation concern</a:t>
+              <a:t>Response to the panel’s validation concern — all numbers re-verified 19 Oct 2026</a:t>
             </a:r>
           </a:p>
         </p:txBody>
@@ -3280,7 +3285,7 @@
         <p:spPr>
           <a:xfrm>
             <a:off x="411480" y="1920240"/>
-            <a:ext cx="3657600" cy="1874519"/>
+            <a:ext cx="3657600" cy="1755648"/>
           </a:xfrm>
           <a:prstGeom prst="roundRect">
             <a:avLst>
@@ -3325,8 +3330,8 @@
         </p:nvSpPr>
         <p:spPr>
           <a:xfrm>
-            <a:off x="640080" y="2048256"/>
-            <a:ext cx="3246120" cy="274320"/>
+            <a:off x="640080" y="2029968"/>
+            <a:ext cx="3246120" cy="256032"/>
           </a:xfrm>
           <a:prstGeom prst="rect">
             <a:avLst/>
@@ -3364,7 +3369,7 @@
         </p:nvSpPr>
         <p:spPr>
           <a:xfrm>
-            <a:off x="640080" y="2304288"/>
+            <a:off x="640080" y="2267712"/>
             <a:ext cx="3246120" cy="1371600"/>
           </a:xfrm>
           <a:prstGeom prst="rect">
@@ -3380,7 +3385,7 @@
           <a:p>
             <a:pPr algn="l">
               <a:spcAft>
-                <a:spcPts val="600"/>
+                <a:spcPts val="500"/>
               </a:spcAft>
             </a:pPr>
             <a:r>
@@ -3390,13 +3395,13 @@
                 </a:solidFill>
                 <a:latin typeface="Segoe UI"/>
               </a:rPr>
-              <a:t>Model trained on 100% synthetic data (25,000 rows) — no real-disaster validation.</a:t>
+              <a:t>Model trained on 100% synthetic data (25,000 rows).</a:t>
             </a:r>
           </a:p>
           <a:p>
             <a:pPr algn="l">
               <a:spcAft>
-                <a:spcPts val="300"/>
+                <a:spcPts val="200"/>
               </a:spcAft>
             </a:pPr>
             <a:r>
@@ -3406,7 +3411,7 @@
                 </a:solidFill>
                 <a:latin typeface="Segoe UI"/>
               </a:rPr>
-              <a:t>External check vs 30 real IDMC flood events:</a:t>
+              <a:t>Real-event test (30 IDMC floods):</a:t>
             </a:r>
           </a:p>
           <a:p>
@@ -3422,7 +3427,7 @@
                 </a:solidFill>
                 <a:latin typeface="Segoe UI"/>
               </a:rPr>
-              <a:t>AUC 0.50 (chance) · 0/30 events found</a:t>
+              <a:t>AUC 0.50 (chance) · 0/30 events · Ditwah missed</a:t>
             </a:r>
           </a:p>
         </p:txBody>
@@ -3435,8 +3440,8 @@
         </p:nvSpPr>
         <p:spPr>
           <a:xfrm>
-            <a:off x="640080" y="3456432"/>
-            <a:ext cx="3246120" cy="274320"/>
+            <a:off x="640080" y="3337560"/>
+            <a:ext cx="3246120" cy="256032"/>
           </a:xfrm>
           <a:prstGeom prst="rect">
             <a:avLst/>
@@ -3471,7 +3476,7 @@
         <p:spPr>
           <a:xfrm>
             <a:off x="4261104" y="1920240"/>
-            <a:ext cx="3657600" cy="1874519"/>
+            <a:ext cx="3657600" cy="1755648"/>
           </a:xfrm>
           <a:prstGeom prst="roundRect">
             <a:avLst>
@@ -3516,8 +3521,8 @@
         </p:nvSpPr>
         <p:spPr>
           <a:xfrm>
-            <a:off x="4489704" y="2048256"/>
-            <a:ext cx="3246120" cy="274320"/>
+            <a:off x="4489704" y="2029968"/>
+            <a:ext cx="3246120" cy="256032"/>
           </a:xfrm>
           <a:prstGeom prst="rect">
             <a:avLst/>
@@ -3555,8 +3560,8 @@
         </p:nvSpPr>
         <p:spPr>
           <a:xfrm>
-            <a:off x="4489704" y="2304288"/>
-            <a:ext cx="3246120" cy="1417320"/>
+            <a:off x="4489704" y="2267712"/>
+            <a:ext cx="3246120" cy="1371600"/>
           </a:xfrm>
           <a:prstGeom prst="rect">
             <a:avLst/>
@@ -3597,7 +3602,7 @@
                 </a:solidFill>
                 <a:latin typeface="Segoe UI"/>
               </a:rPr>
-              <a:t>• Scraped DMC daily river water-level reports</a:t>
+              <a:t>• Scraped DMC daily river water-level PDF reports</a:t>
             </a:r>
           </a:p>
           <a:p>
@@ -3613,7 +3618,7 @@
                 </a:solidFill>
                 <a:latin typeface="Segoe UI"/>
               </a:rPr>
-              <a:t>• ERA5 rainfall · SRTM elevation · IDMC events</a:t>
+              <a:t>• Merged ERA5 rainfall · SRTM elevation · IDMC events</a:t>
             </a:r>
           </a:p>
           <a:p>
@@ -3643,7 +3648,7 @@
         <p:spPr>
           <a:xfrm>
             <a:off x="8110727" y="1920240"/>
-            <a:ext cx="3666744" cy="1874519"/>
+            <a:ext cx="3666744" cy="1755648"/>
           </a:xfrm>
           <a:prstGeom prst="roundRect">
             <a:avLst>
@@ -3688,8 +3693,8 @@
         </p:nvSpPr>
         <p:spPr>
           <a:xfrm>
-            <a:off x="8339327" y="2048256"/>
-            <a:ext cx="3246120" cy="274320"/>
+            <a:off x="8339327" y="2029968"/>
+            <a:ext cx="3246120" cy="256032"/>
           </a:xfrm>
           <a:prstGeom prst="rect">
             <a:avLst/>
@@ -3727,8 +3732,8 @@
         </p:nvSpPr>
         <p:spPr>
           <a:xfrm>
-            <a:off x="8339327" y="2304288"/>
-            <a:ext cx="3246120" cy="1417320"/>
+            <a:off x="8339327" y="2267712"/>
+            <a:ext cx="3291840" cy="1371600"/>
           </a:xfrm>
           <a:prstGeom prst="rect">
             <a:avLst/>
@@ -3743,7 +3748,7 @@
           <a:p>
             <a:pPr algn="l">
               <a:spcAft>
-                <a:spcPts val="500"/>
+                <a:spcPts val="400"/>
               </a:spcAft>
             </a:pPr>
             <a:r>
@@ -3753,7 +3758,7 @@
                 </a:solidFill>
                 <a:latin typeface="Segoe UI"/>
               </a:rPr>
-              <a:t>Retrained on real data (temporal split, threshold 0.58).</a:t>
+              <a:t>Retrained on real data; same production features.</a:t>
             </a:r>
           </a:p>
           <a:p>
@@ -3769,7 +3774,7 @@
                 </a:solidFill>
                 <a:latin typeface="Segoe UI"/>
               </a:rPr>
-              <a:t>• Gauge water level becomes key feature (importance 0.63)</a:t>
+              <a:t>• Gauge water level is key feature (importance 0.63)</a:t>
             </a:r>
           </a:p>
           <a:p>
@@ -3785,7 +3790,7 @@
                 </a:solidFill>
                 <a:latin typeface="Segoe UI"/>
               </a:rPr>
-              <a:t>• Same production feature vector — drop-in replacement</a:t>
+              <a:t>• Threshold 0.570 chosen on validation split only</a:t>
             </a:r>
           </a:p>
           <a:p>
@@ -3801,7 +3806,7 @@
                 </a:solidFill>
                 <a:latin typeface="Segoe UI"/>
               </a:rPr>
-              <a:t>• Synthetic model kept as backup for comparison</a:t>
+              <a:t>• Test split evaluated once at frozen threshold</a:t>
             </a:r>
           </a:p>
         </p:txBody>
@@ -3814,8 +3819,8 @@
         </p:nvSpPr>
         <p:spPr>
           <a:xfrm>
-            <a:off x="411480" y="3950208"/>
-            <a:ext cx="7507224" cy="2542032"/>
+            <a:off x="411480" y="3822191"/>
+            <a:ext cx="7507224" cy="2697480"/>
           </a:xfrm>
           <a:prstGeom prst="roundRect">
             <a:avLst>
@@ -3860,8 +3865,8 @@
         </p:nvSpPr>
         <p:spPr>
           <a:xfrm>
-            <a:off x="640080" y="4078224"/>
-            <a:ext cx="7040880" cy="274320"/>
+            <a:off x="640080" y="3931919"/>
+            <a:ext cx="7040880" cy="256032"/>
           </a:xfrm>
           <a:prstGeom prst="rect">
             <a:avLst/>
@@ -3899,8 +3904,8 @@
         </p:nvSpPr>
         <p:spPr>
           <a:xfrm>
-            <a:off x="640080" y="4334256"/>
-            <a:ext cx="7040880" cy="365760"/>
+            <a:off x="640080" y="4169663"/>
+            <a:ext cx="7040880" cy="292608"/>
           </a:xfrm>
           <a:prstGeom prst="rect">
             <a:avLst/>
@@ -3938,8 +3943,8 @@
         </p:nvSpPr>
         <p:spPr>
           <a:xfrm>
-            <a:off x="640080" y="4754880"/>
-            <a:ext cx="1417320" cy="713232"/>
+            <a:off x="640080" y="4535423"/>
+            <a:ext cx="1417320" cy="658368"/>
           </a:xfrm>
           <a:prstGeom prst="roundRect">
             <a:avLst>
@@ -3984,8 +3989,8 @@
         </p:nvSpPr>
         <p:spPr>
           <a:xfrm>
-            <a:off x="713232" y="4809744"/>
-            <a:ext cx="1271016" cy="621792"/>
+            <a:off x="713232" y="4581143"/>
+            <a:ext cx="1271016" cy="585216"/>
           </a:xfrm>
           <a:prstGeom prst="rect">
             <a:avLst/>
@@ -4039,8 +4044,8 @@
         </p:nvSpPr>
         <p:spPr>
           <a:xfrm>
-            <a:off x="2167128" y="4754880"/>
-            <a:ext cx="1417320" cy="713232"/>
+            <a:off x="2167128" y="4535423"/>
+            <a:ext cx="1417320" cy="658368"/>
           </a:xfrm>
           <a:prstGeom prst="roundRect">
             <a:avLst>
@@ -4085,8 +4090,8 @@
         </p:nvSpPr>
         <p:spPr>
           <a:xfrm>
-            <a:off x="2240280" y="4809744"/>
-            <a:ext cx="1271016" cy="621792"/>
+            <a:off x="2240280" y="4581143"/>
+            <a:ext cx="1271016" cy="585216"/>
           </a:xfrm>
           <a:prstGeom prst="rect">
             <a:avLst/>
@@ -4140,8 +4145,8 @@
         </p:nvSpPr>
         <p:spPr>
           <a:xfrm>
-            <a:off x="3694176" y="4754880"/>
-            <a:ext cx="1417320" cy="713232"/>
+            <a:off x="3694176" y="4535423"/>
+            <a:ext cx="1417320" cy="658368"/>
           </a:xfrm>
           <a:prstGeom prst="roundRect">
             <a:avLst>
@@ -4186,8 +4191,8 @@
         </p:nvSpPr>
         <p:spPr>
           <a:xfrm>
-            <a:off x="3767328" y="4809744"/>
-            <a:ext cx="1271016" cy="621792"/>
+            <a:off x="3767328" y="4581143"/>
+            <a:ext cx="1271016" cy="585216"/>
           </a:xfrm>
           <a:prstGeom prst="rect">
             <a:avLst/>
@@ -4241,8 +4246,8 @@
         </p:nvSpPr>
         <p:spPr>
           <a:xfrm>
-            <a:off x="5221224" y="4754880"/>
-            <a:ext cx="1965960" cy="713232"/>
+            <a:off x="5221224" y="4535423"/>
+            <a:ext cx="1965960" cy="658368"/>
           </a:xfrm>
           <a:prstGeom prst="roundRect">
             <a:avLst>
@@ -4287,8 +4292,8 @@
         </p:nvSpPr>
         <p:spPr>
           <a:xfrm>
-            <a:off x="5294376" y="4809744"/>
-            <a:ext cx="1819656" cy="621792"/>
+            <a:off x="5294376" y="4581143"/>
+            <a:ext cx="1819656" cy="585216"/>
           </a:xfrm>
           <a:prstGeom prst="rect">
             <a:avLst/>
@@ -4342,8 +4347,8 @@
         </p:nvSpPr>
         <p:spPr>
           <a:xfrm>
-            <a:off x="640080" y="5596128"/>
-            <a:ext cx="7040880" cy="822960"/>
+            <a:off x="640080" y="5285231"/>
+            <a:ext cx="7040880" cy="457200"/>
           </a:xfrm>
           <a:prstGeom prst="rect">
             <a:avLst/>
@@ -4358,7 +4363,7 @@
           <a:p>
             <a:pPr algn="l">
               <a:spcAft>
-                <a:spcPts val="400"/>
+                <a:spcPts val="0"/>
               </a:spcAft>
             </a:pPr>
             <a:r>
@@ -4368,7 +4373,7 @@
                 </a:solidFill>
                 <a:latin typeface="Segoe UI"/>
               </a:rPr>
-              <a:t>Sources: DMC water-level PDF reports · ERA5 (Open-Meteo) · SRTM elevation · IDMC flood events</a:t>
+              <a:t>Built by build_real_flood_dataset.py: scrape DMC water-level PDFs → merge ERA5 + SRTM → label = DMC flood status.</a:t>
             </a:r>
           </a:p>
         </p:txBody>
@@ -4381,8 +4386,8 @@
         </p:nvSpPr>
         <p:spPr>
           <a:xfrm>
-            <a:off x="640080" y="5833872"/>
-            <a:ext cx="7040880" cy="502920"/>
+            <a:off x="640080" y="5605271"/>
+            <a:ext cx="7040880" cy="777240"/>
           </a:xfrm>
           <a:prstGeom prst="rect">
             <a:avLst/>
@@ -4396,13 +4401,40 @@
           <a:lstStyle/>
           <a:p>
             <a:r>
+              <a:rPr sz="1000" u="sng">
+                <a:solidFill>
+                  <a:srgbClr val="0071E3"/>
+                </a:solidFill>
+                <a:latin typeface="Segoe UI"/>
+                <a:hlinkClick r:id="rId3"/>
+              </a:rPr>
+              <a:t>↓  Download DMC daily water-level PDF reports (source of labels)</a:t>
+            </a:r>
+          </a:p>
+          <a:p>
+            <a:pPr>
+              <a:spcBef>
+                <a:spcPts val="300"/>
+              </a:spcBef>
+            </a:pPr>
+            <a:r>
+              <a:rPr sz="950" u="sng">
+                <a:solidFill>
+                  <a:srgbClr val="0071E3"/>
+                </a:solidFill>
+                <a:latin typeface="Segoe UI"/>
+                <a:hlinkClick r:id="rId4"/>
+              </a:rPr>
+              <a:t>Dataset CSV in repo</a:t>
+            </a:r>
+            <a:r>
               <a:rPr sz="950">
                 <a:solidFill>
                   <a:srgbClr val="6E6E73"/>
                 </a:solidFill>
                 <a:latin typeface="Segoe UI"/>
               </a:rPr>
-              <a:t>Dataset: </a:t>
+              <a:t>  ·  Full validation report: </a:t>
             </a:r>
             <a:r>
               <a:rPr sz="950" u="sng">
@@ -4410,39 +4442,9 @@
                   <a:srgbClr val="0071E3"/>
                 </a:solidFill>
                 <a:latin typeface="Segoe UI"/>
-                <a:hlinkClick r:id="rId3"/>
-              </a:rPr>
-              <a:t>repo/…/sri_lanka_flood_real_dataset.csv</a:t>
-            </a:r>
-            <a:r>
-              <a:rPr sz="950">
-                <a:solidFill>
-                  <a:srgbClr val="6E6E73"/>
-                </a:solidFill>
-                <a:latin typeface="Segoe UI"/>
-              </a:rPr>
-              <a:t>   ·   Sources: dmc.gov.lk · internal-displacement.org · open-meteo.com</a:t>
-            </a:r>
-          </a:p>
-          <a:p>
-            <a:r>
-              <a:rPr sz="950">
-                <a:solidFill>
-                  <a:srgbClr val="6E6E73"/>
-                </a:solidFill>
-                <a:latin typeface="Segoe UI"/>
-              </a:rPr>
-              <a:t>Full report: </a:t>
-            </a:r>
-            <a:r>
-              <a:rPr sz="950" u="sng">
-                <a:solidFill>
-                  <a:srgbClr val="0071E3"/>
-                </a:solidFill>
-                <a:latin typeface="Segoe UI"/>
-                <a:hlinkClick r:id="rId4"/>
-              </a:rPr>
-              <a:t>VALIDATION_REPORT.md (repo)</a:t>
+                <a:hlinkClick r:id="rId5"/>
+              </a:rPr>
+              <a:t>VALIDATION_REPORT.md</a:t>
             </a:r>
           </a:p>
         </p:txBody>
@@ -4455,8 +4457,8 @@
         </p:nvSpPr>
         <p:spPr>
           <a:xfrm>
-            <a:off x="8110727" y="3950208"/>
-            <a:ext cx="3666744" cy="2542032"/>
+            <a:off x="8110727" y="3822191"/>
+            <a:ext cx="3666744" cy="2697480"/>
           </a:xfrm>
           <a:prstGeom prst="roundRect">
             <a:avLst>
@@ -4501,8 +4503,8 @@
         </p:nvSpPr>
         <p:spPr>
           <a:xfrm>
-            <a:off x="8339327" y="4078224"/>
-            <a:ext cx="3246120" cy="274320"/>
+            <a:off x="8339327" y="3931919"/>
+            <a:ext cx="3246120" cy="256032"/>
           </a:xfrm>
           <a:prstGeom prst="rect">
             <a:avLst/>
@@ -4523,11 +4525,11 @@
             <a:r>
               <a:rPr sz="900" b="1" i="0">
                 <a:solidFill>
-                  <a:srgbClr val="0071E3"/>
-                </a:solidFill>
-                <a:latin typeface="Segoe UI"/>
-              </a:rPr>
-              <a:t>HOW THE DATASET WAS CREATED</a:t>
+                  <a:srgbClr val="FF9F0A"/>
+                </a:solidFill>
+                <a:latin typeface="Segoe UI"/>
+              </a:rPr>
+              <a:t>THRESHOLD SELECTION (EVIDENCE)</a:t>
             </a:r>
           </a:p>
         </p:txBody>
@@ -4540,8 +4542,8 @@
         </p:nvSpPr>
         <p:spPr>
           <a:xfrm>
-            <a:off x="8339327" y="4361688"/>
-            <a:ext cx="3291840" cy="2011680"/>
+            <a:off x="8339327" y="4187951"/>
+            <a:ext cx="3291840" cy="2240280"/>
           </a:xfrm>
           <a:prstGeom prst="rect">
             <a:avLst/>
@@ -4554,128 +4556,115 @@
           </a:bodyPr>
           <a:lstStyle/>
           <a:p>
-            <a:pPr>
-              <a:spcAft>
-                <a:spcPts val="400"/>
-              </a:spcAft>
-            </a:pPr>
-            <a:r>
-              <a:rPr sz="950" b="1">
-                <a:solidFill>
-                  <a:srgbClr val="0071E3"/>
-                </a:solidFill>
-                <a:latin typeface="Segoe UI"/>
-              </a:rPr>
-              <a:t>1  </a:t>
-            </a:r>
-            <a:r>
-              <a:rPr sz="950">
+            <a:pPr algn="l">
+              <a:spcAft>
+                <a:spcPts val="300"/>
+              </a:spcAft>
+            </a:pPr>
+            <a:r>
+              <a:rPr sz="1000" b="1" i="0">
                 <a:solidFill>
                   <a:srgbClr val="1D1D1F"/>
                 </a:solidFill>
                 <a:latin typeface="Segoe UI"/>
               </a:rPr>
-              <a:t>Scrape DMC water-level PDFs (pdfplumber)</a:t>
-            </a:r>
-          </a:p>
-          <a:p>
-            <a:pPr>
-              <a:spcAft>
-                <a:spcPts val="400"/>
-              </a:spcAft>
-            </a:pPr>
-            <a:r>
-              <a:rPr sz="950" b="1">
-                <a:solidFill>
-                  <a:srgbClr val="0071E3"/>
-                </a:solidFill>
-                <a:latin typeface="Segoe UI"/>
-              </a:rPr>
-              <a:t>2  </a:t>
-            </a:r>
-            <a:r>
-              <a:rPr sz="950">
+              <a:t>Temporal split by date:</a:t>
+            </a:r>
+          </a:p>
+          <a:p>
+            <a:pPr algn="l">
+              <a:spcAft>
+                <a:spcPts val="600"/>
+              </a:spcAft>
+            </a:pPr>
+            <a:r>
+              <a:rPr sz="950" b="0" i="0">
                 <a:solidFill>
                   <a:srgbClr val="1D1D1F"/>
                 </a:solidFill>
                 <a:latin typeface="Segoe UI"/>
               </a:rPr>
-              <a:t>Target dates of known IDMC flood events</a:t>
-            </a:r>
-          </a:p>
-          <a:p>
-            <a:pPr>
-              <a:spcAft>
-                <a:spcPts val="400"/>
-              </a:spcAft>
-            </a:pPr>
-            <a:r>
-              <a:rPr sz="950" b="1">
-                <a:solidFill>
-                  <a:srgbClr val="0071E3"/>
-                </a:solidFill>
-                <a:latin typeface="Segoe UI"/>
-              </a:rPr>
-              <a:t>3  </a:t>
-            </a:r>
-            <a:r>
-              <a:rPr sz="950">
+              <a:t>Train &lt; Feb’26 (2,483) · Val Feb–Jun’26 (428) · Test ≥ Jul’26 (424, untouched)</a:t>
+            </a:r>
+          </a:p>
+          <a:p>
+            <a:pPr algn="l">
+              <a:spcAft>
+                <a:spcPts val="300"/>
+              </a:spcAft>
+            </a:pPr>
+            <a:r>
+              <a:rPr sz="1000" b="1" i="0">
                 <a:solidFill>
                   <a:srgbClr val="1D1D1F"/>
                 </a:solidFill>
                 <a:latin typeface="Segoe UI"/>
               </a:rPr>
-              <a:t>Merge ERA5 rain + SRTM elevation per station-day</a:t>
-            </a:r>
-          </a:p>
-          <a:p>
-            <a:pPr>
-              <a:spcAft>
-                <a:spcPts val="400"/>
-              </a:spcAft>
-            </a:pPr>
-            <a:r>
-              <a:rPr sz="950" b="1">
-                <a:solidFill>
-                  <a:srgbClr val="0071E3"/>
-                </a:solidFill>
-                <a:latin typeface="Segoe UI"/>
-              </a:rPr>
-              <a:t>4  </a:t>
-            </a:r>
-            <a:r>
-              <a:rPr sz="950">
+              <a:t>F2-optimal threshold on VALIDATION only:</a:t>
+            </a:r>
+          </a:p>
+          <a:p>
+            <a:pPr algn="l">
+              <a:spcAft>
+                <a:spcPts val="600"/>
+              </a:spcAft>
+            </a:pPr>
+            <a:r>
+              <a:rPr sz="950" b="0" i="0">
                 <a:solidFill>
                   <a:srgbClr val="1D1D1F"/>
                 </a:solidFill>
                 <a:latin typeface="Segoe UI"/>
               </a:rPr>
-              <a:t>Label = DMC status: Minor/Major Flood → 1, Normal → 0</a:t>
-            </a:r>
-          </a:p>
-          <a:p>
-            <a:pPr>
-              <a:spcAft>
-                <a:spcPts val="400"/>
-              </a:spcAft>
-            </a:pPr>
-            <a:r>
-              <a:rPr sz="950" b="1">
-                <a:solidFill>
-                  <a:srgbClr val="0071E3"/>
-                </a:solidFill>
-                <a:latin typeface="Segoe UI"/>
-              </a:rPr>
-              <a:t>5  </a:t>
-            </a:r>
-            <a:r>
-              <a:rPr sz="950">
+              <a:t>→ 0.570 (F1-optimal also 0.570 — both agree)</a:t>
+            </a:r>
+          </a:p>
+          <a:p>
+            <a:pPr algn="l">
+              <a:spcAft>
+                <a:spcPts val="600"/>
+              </a:spcAft>
+            </a:pPr>
+            <a:r>
+              <a:rPr sz="950" b="0" i="0">
+                <a:solidFill>
+                  <a:srgbClr val="6E6E73"/>
+                </a:solidFill>
+                <a:latin typeface="Segoe UI"/>
+              </a:rPr>
+              <a:t>Why F2: in disaster warning, a missed flood costs more than a false alarm (recall weighted 4× precision).</a:t>
+            </a:r>
+          </a:p>
+          <a:p>
+            <a:pPr algn="l">
+              <a:spcAft>
+                <a:spcPts val="300"/>
+              </a:spcAft>
+            </a:pPr>
+            <a:r>
+              <a:rPr sz="1000" b="1" i="0">
                 <a:solidFill>
                   <a:srgbClr val="1D1D1F"/>
                 </a:solidFill>
                 <a:latin typeface="Segoe UI"/>
               </a:rPr>
-              <a:t>Automated pipeline: build_real_flood_dataset.py</a:t>
+              <a:t>Test evaluated once at frozen 0.570:</a:t>
+            </a:r>
+          </a:p>
+          <a:p>
+            <a:pPr algn="l">
+              <a:spcAft>
+                <a:spcPts val="0"/>
+              </a:spcAft>
+            </a:pPr>
+            <a:r>
+              <a:rPr sz="950" b="0" i="0">
+                <a:solidFill>
+                  <a:srgbClr val="1D1D1F"/>
+                </a:solidFill>
+                <a:latin typeface="Segoe UI"/>
+              </a:rPr>
+              <a:t>AUC 1.000 · P 1.000 · R 0.800 · F1 0.889 (only 5 test flood-days — weak alone; external test is main evidence)</a:t>
             </a:r>
           </a:p>
         </p:txBody>
@@ -4779,7 +4768,7 @@
                 </a:solidFill>
                 <a:latin typeface="Segoe UI"/>
               </a:rPr>
-              <a:t>Validated against Cyclone Ditwah &amp; 30 IDMC flood events vs 500 non-flood controls</a:t>
+              <a:t>Validated on Cyclone Ditwah (case study) + 30 documented IDMC flood events vs 500 control locations</a:t>
             </a:r>
           </a:p>
         </p:txBody>
@@ -4793,7 +4782,7 @@
         <p:spPr>
           <a:xfrm>
             <a:off x="411480" y="1078992"/>
-            <a:ext cx="7507224" cy="1481328"/>
+            <a:ext cx="7507224" cy="1554480"/>
           </a:xfrm>
           <a:prstGeom prst="roundRect">
             <a:avLst>
@@ -4838,8 +4827,8 @@
         </p:nvSpPr>
         <p:spPr>
           <a:xfrm>
-            <a:off x="640080" y="1188720"/>
-            <a:ext cx="7040880" cy="274320"/>
+            <a:off x="640080" y="1170432"/>
+            <a:ext cx="7040880" cy="256032"/>
           </a:xfrm>
           <a:prstGeom prst="rect">
             <a:avLst/>
@@ -4864,7 +4853,7 @@
                 </a:solidFill>
                 <a:latin typeface="Segoe UI"/>
               </a:rPr>
-              <a:t>ACTUAL SCENARIO — CYCLONE DITWAH, POLONNARUWA (27 NOV – 3 DEC 2025)</a:t>
+              <a:t>CASE STUDY — CYCLONE DITWAH, POLONNARUWA (27 NOV – 3 DEC 2025)</a:t>
             </a:r>
           </a:p>
         </p:txBody>
@@ -4877,8 +4866,8 @@
         </p:nvSpPr>
         <p:spPr>
           <a:xfrm>
-            <a:off x="640080" y="1463040"/>
-            <a:ext cx="7040880" cy="1005840"/>
+            <a:off x="640080" y="1426464"/>
+            <a:ext cx="7040880" cy="1143000"/>
           </a:xfrm>
           <a:prstGeom prst="rect">
             <a:avLst/>
@@ -4903,23 +4892,27 @@
                 </a:solidFill>
                 <a:latin typeface="Segoe UI"/>
               </a:rPr>
-              <a:t>Real inputs: rain 255.8 mm/7d (ERA5) · elev. 39 m (SRTM) · Manampitiya gauge, Mahaweli Ganga — level 4.3 m = minor-flood threshold · 13,365 people displaced (IDMC/DMC).</a:t>
-            </a:r>
-          </a:p>
-          <a:p>
-            <a:pPr algn="l">
-              <a:spcAft>
-                <a:spcPts val="0"/>
-              </a:spcAft>
-            </a:pPr>
-            <a:r>
-              <a:rPr sz="1000" b="0" i="0">
-                <a:solidFill>
-                  <a:srgbClr val="6E6E73"/>
-                </a:solidFill>
-                <a:latin typeface="Segoe UI"/>
-              </a:rPr>
-              <a:t>30-event study: IDMC Sri Lanka floods (2025–26) vs 500 non-flood control days.</a:t>
+              <a:t>Real inputs: rain 255.8 mm/7d (ERA5) · elev. 39 m (SRTM) · Manampitiya gauge, Mahaweli Ganga — level 4.3 m = minor-flood stage · 13,365 displaced (IDMC/DMC).</a:t>
+            </a:r>
+          </a:p>
+          <a:p>
+            <a:r>
+              <a:rPr sz="1050" b="1">
+                <a:solidFill>
+                  <a:srgbClr val="FF3B30"/>
+                </a:solidFill>
+                <a:latin typeface="Segoe UI"/>
+              </a:rPr>
+              <a:t>Old synthetic model: 0.000 → “No flood” ✗ missed   </a:t>
+            </a:r>
+            <a:r>
+              <a:rPr sz="1050" b="1">
+                <a:solidFill>
+                  <a:srgbClr val="30D158"/>
+                </a:solidFill>
+                <a:latin typeface="Segoe UI"/>
+              </a:rPr>
+              <a:t>→   New real-data model: 0.853 → “Flood” ✓ correct</a:t>
             </a:r>
           </a:p>
         </p:txBody>
@@ -4933,7 +4926,7 @@
         <p:spPr>
           <a:xfrm>
             <a:off x="8110727" y="1078992"/>
-            <a:ext cx="3666744" cy="1481328"/>
+            <a:ext cx="3666744" cy="1554480"/>
           </a:xfrm>
           <a:prstGeom prst="roundRect">
             <a:avLst>
@@ -4978,8 +4971,8 @@
         </p:nvSpPr>
         <p:spPr>
           <a:xfrm>
-            <a:off x="8339327" y="1188720"/>
-            <a:ext cx="3246120" cy="274320"/>
+            <a:off x="8339327" y="1170432"/>
+            <a:ext cx="3246120" cy="256032"/>
           </a:xfrm>
           <a:prstGeom prst="rect">
             <a:avLst/>
@@ -5017,8 +5010,8 @@
         </p:nvSpPr>
         <p:spPr>
           <a:xfrm>
-            <a:off x="8339327" y="1444752"/>
-            <a:ext cx="3291840" cy="1097280"/>
+            <a:off x="8339327" y="1408176"/>
+            <a:ext cx="3291840" cy="1143000"/>
           </a:xfrm>
           <a:prstGeom prst="rect">
             <a:avLst/>
@@ -5078,7 +5071,7 @@
                 <a:latin typeface="Segoe UI"/>
                 <a:hlinkClick r:id="rId4"/>
               </a:rPr>
-              <a:t>↗  DMC — river water levels</a:t>
+              <a:t>↗  ↓ DMC water-level PDF reports</a:t>
             </a:r>
           </a:p>
           <a:p>
@@ -5108,8 +5101,8 @@
         </p:nvSpPr>
         <p:spPr>
           <a:xfrm>
-            <a:off x="411480" y="2706624"/>
-            <a:ext cx="3657600" cy="1755648"/>
+            <a:off x="411480" y="2779776"/>
+            <a:ext cx="3657600" cy="1810512"/>
           </a:xfrm>
           <a:prstGeom prst="roundRect">
             <a:avLst>
@@ -5154,8 +5147,8 @@
         </p:nvSpPr>
         <p:spPr>
           <a:xfrm>
-            <a:off x="640080" y="2816352"/>
-            <a:ext cx="3246120" cy="274320"/>
+            <a:off x="640080" y="2871216"/>
+            <a:ext cx="3246120" cy="256032"/>
           </a:xfrm>
           <a:prstGeom prst="rect">
             <a:avLst/>
@@ -5180,7 +5173,7 @@
                 </a:solidFill>
                 <a:latin typeface="Segoe UI"/>
               </a:rPr>
-              <a:t>FLOOD SCENARIO — VALIDATION RESULT</a:t>
+              <a:t>FLOOD SCENARIOS — REAL EVENTS</a:t>
             </a:r>
           </a:p>
         </p:txBody>
@@ -5193,8 +5186,8 @@
         </p:nvSpPr>
         <p:spPr>
           <a:xfrm>
-            <a:off x="640080" y="3090672"/>
-            <a:ext cx="3246120" cy="1325880"/>
+            <a:off x="640080" y="3127248"/>
+            <a:ext cx="3246120" cy="1417320"/>
           </a:xfrm>
           <a:prstGeom prst="rect">
             <a:avLst/>
@@ -5219,7 +5212,7 @@
                 </a:solidFill>
                 <a:latin typeface="Segoe UI"/>
               </a:rPr>
-              <a:t>27 / 30 real flood events detected (90%)</a:t>
+              <a:t>26 / 30 real flood events detected (87%)</a:t>
             </a:r>
           </a:p>
           <a:p>
@@ -5235,7 +5228,7 @@
                 </a:solidFill>
                 <a:latin typeface="Segoe UI"/>
               </a:rPr>
-              <a:t>ROC-AUC 0.948 with live gauge stage</a:t>
+              <a:t>ROC-AUC 0.930 with real gauge stage</a:t>
             </a:r>
           </a:p>
           <a:p>
@@ -5251,7 +5244,7 @@
                 </a:solidFill>
                 <a:latin typeface="Segoe UI"/>
               </a:rPr>
-              <a:t>Ditwah Polonnaruwa: 0.763 → FLOOD (correct)</a:t>
+              <a:t>Eravur Pattu (803 displaced): 0.058 → 0.679 ✓</a:t>
             </a:r>
           </a:p>
           <a:p>
@@ -5263,11 +5256,11 @@
             <a:r>
               <a:rPr sz="1000" b="0" i="0">
                 <a:solidFill>
-                  <a:srgbClr val="1D1D1F"/>
-                </a:solidFill>
-                <a:latin typeface="Segoe UI"/>
-              </a:rPr>
-              <a:t>Eravur Pattu: 0.905 → FLOOD (correct)</a:t>
+                  <a:srgbClr val="6E6E73"/>
+                </a:solidFill>
+                <a:latin typeface="Segoe UI"/>
+              </a:rPr>
+              <a:t>Mean prob: 0.74 events vs 0.22 controls</a:t>
             </a:r>
           </a:p>
         </p:txBody>
@@ -5280,8 +5273,8 @@
         </p:nvSpPr>
         <p:spPr>
           <a:xfrm>
-            <a:off x="4261104" y="2706624"/>
-            <a:ext cx="3657600" cy="1755648"/>
+            <a:off x="4261104" y="2779776"/>
+            <a:ext cx="3657600" cy="1810512"/>
           </a:xfrm>
           <a:prstGeom prst="roundRect">
             <a:avLst>
@@ -5326,8 +5319,8 @@
         </p:nvSpPr>
         <p:spPr>
           <a:xfrm>
-            <a:off x="4489704" y="2816352"/>
-            <a:ext cx="3246120" cy="274320"/>
+            <a:off x="4489704" y="2871216"/>
+            <a:ext cx="3246120" cy="256032"/>
           </a:xfrm>
           <a:prstGeom prst="rect">
             <a:avLst/>
@@ -5352,7 +5345,7 @@
                 </a:solidFill>
                 <a:latin typeface="Segoe UI"/>
               </a:rPr>
-              <a:t>NON-FLOOD SCENARIO — VALIDATION RESULT</a:t>
+              <a:t>NON-FLOOD SCENARIOS — CONTROLS</a:t>
             </a:r>
           </a:p>
         </p:txBody>
@@ -5365,8 +5358,8 @@
         </p:nvSpPr>
         <p:spPr>
           <a:xfrm>
-            <a:off x="4489704" y="3090672"/>
-            <a:ext cx="3246120" cy="1325880"/>
+            <a:off x="4489704" y="3127248"/>
+            <a:ext cx="3246120" cy="1417320"/>
           </a:xfrm>
           <a:prstGeom prst="rect">
             <a:avLst/>
@@ -5381,17 +5374,33 @@
           <a:p>
             <a:pPr algn="l">
               <a:spcAft>
+                <a:spcPts val="300"/>
+              </a:spcAft>
+            </a:pPr>
+            <a:r>
+              <a:rPr sz="1200" b="1" i="0">
+                <a:solidFill>
+                  <a:srgbClr val="30D158"/>
+                </a:solidFill>
+                <a:latin typeface="Segoe UI"/>
+              </a:rPr>
+              <a:t>500 control locations kept mostly low</a:t>
+            </a:r>
+          </a:p>
+          <a:p>
+            <a:pPr algn="l">
+              <a:spcAft>
                 <a:spcPts val="400"/>
               </a:spcAft>
             </a:pPr>
             <a:r>
-              <a:rPr sz="1200" b="1" i="0">
-                <a:solidFill>
-                  <a:srgbClr val="30D158"/>
-                </a:solidFill>
-                <a:latin typeface="Segoe UI"/>
-              </a:rPr>
-              <a:t>500 control (non-flood) days correctly low</a:t>
+              <a:rPr sz="900" b="0" i="0">
+                <a:solidFill>
+                  <a:srgbClr val="6E6E73"/>
+                </a:solidFill>
+                <a:latin typeface="Segoe UI"/>
+              </a:rPr>
+              <a:t>Controls = places with no documented flood within 10 km (assumed no-flood days)</a:t>
             </a:r>
           </a:p>
           <a:p>
@@ -5401,45 +5410,29 @@
               </a:spcAft>
             </a:pPr>
             <a:r>
-              <a:rPr sz="1050" b="0" i="0">
+              <a:rPr sz="1000" b="0" i="0">
                 <a:solidFill>
                   <a:srgbClr val="1D1D1F"/>
                 </a:solidFill>
                 <a:latin typeface="Segoe UI"/>
               </a:rPr>
-              <a:t>Mean probability: 0.22 vs 0.81 for events</a:t>
+              <a:t>89% (444/500) correctly below threshold</a:t>
             </a:r>
           </a:p>
           <a:p>
             <a:pPr algn="l">
               <a:spcAft>
-                <a:spcPts val="300"/>
+                <a:spcPts val="0"/>
               </a:spcAft>
             </a:pPr>
             <a:r>
               <a:rPr sz="1000" b="0" i="0">
                 <a:solidFill>
-                  <a:srgbClr val="1D1D1F"/>
-                </a:solidFill>
-                <a:latin typeface="Segoe UI"/>
-              </a:rPr>
-              <a:t>No false flood flags at normal gauge levels</a:t>
-            </a:r>
-          </a:p>
-          <a:p>
-            <a:pPr algn="l">
-              <a:spcAft>
-                <a:spcPts val="0"/>
-              </a:spcAft>
-            </a:pPr>
-            <a:r>
-              <a:rPr sz="1000" b="0" i="0">
-                <a:solidFill>
-                  <a:srgbClr val="6E6E73"/>
-                </a:solidFill>
-                <a:latin typeface="Segoe UI"/>
-              </a:rPr>
-              <a:t>Precision 0.39 · F1 0.545 (class-imbalanced)</a:t>
+                  <a:srgbClr val="FF9F0A"/>
+                </a:solidFill>
+                <a:latin typeface="Segoe UI"/>
+              </a:rPr>
+              <a:t>11% (56/500) false alarms — stated honestly</a:t>
             </a:r>
           </a:p>
         </p:txBody>
@@ -5452,8 +5445,8 @@
         </p:nvSpPr>
         <p:spPr>
           <a:xfrm>
-            <a:off x="8110727" y="2706624"/>
-            <a:ext cx="3666744" cy="1755648"/>
+            <a:off x="8110727" y="2779776"/>
+            <a:ext cx="3666744" cy="1810512"/>
           </a:xfrm>
           <a:prstGeom prst="roundRect">
             <a:avLst>
@@ -5498,8 +5491,8 @@
         </p:nvSpPr>
         <p:spPr>
           <a:xfrm>
-            <a:off x="8339327" y="2816352"/>
-            <a:ext cx="3246120" cy="274320"/>
+            <a:off x="8339327" y="2871216"/>
+            <a:ext cx="3246120" cy="256032"/>
           </a:xfrm>
           <a:prstGeom prst="rect">
             <a:avLst/>
@@ -5537,7 +5530,7 @@
         </p:nvSpPr>
         <p:spPr>
           <a:xfrm>
-            <a:off x="8339327" y="3090672"/>
+            <a:off x="8339327" y="3145536"/>
             <a:ext cx="1353312" cy="201168"/>
           </a:xfrm>
           <a:prstGeom prst="rect">
@@ -5576,7 +5569,7 @@
         </p:nvSpPr>
         <p:spPr>
           <a:xfrm>
-            <a:off x="9710928" y="3090672"/>
+            <a:off x="9710928" y="3145536"/>
             <a:ext cx="1078992" cy="201168"/>
           </a:xfrm>
           <a:prstGeom prst="rect">
@@ -5615,7 +5608,7 @@
         </p:nvSpPr>
         <p:spPr>
           <a:xfrm>
-            <a:off x="10808208" y="3090672"/>
+            <a:off x="10808208" y="3145536"/>
             <a:ext cx="1005840" cy="201168"/>
           </a:xfrm>
           <a:prstGeom prst="rect">
@@ -5654,7 +5647,7 @@
         </p:nvSpPr>
         <p:spPr>
           <a:xfrm>
-            <a:off x="8339327" y="3310128"/>
+            <a:off x="8339327" y="3346704"/>
             <a:ext cx="1353312" cy="256032"/>
           </a:xfrm>
           <a:prstGeom prst="rect">
@@ -5693,7 +5686,7 @@
         </p:nvSpPr>
         <p:spPr>
           <a:xfrm>
-            <a:off x="9710928" y="3310128"/>
+            <a:off x="9710928" y="3346704"/>
             <a:ext cx="1078992" cy="256032"/>
           </a:xfrm>
           <a:prstGeom prst="rect">
@@ -5732,7 +5725,7 @@
         </p:nvSpPr>
         <p:spPr>
           <a:xfrm>
-            <a:off x="10808208" y="3310128"/>
+            <a:off x="10808208" y="3346704"/>
             <a:ext cx="1005840" cy="256032"/>
           </a:xfrm>
           <a:prstGeom prst="rect">
@@ -5758,7 +5751,7 @@
                 </a:solidFill>
                 <a:latin typeface="Segoe UI"/>
               </a:rPr>
-              <a:t>0.763 → Yes ✓</a:t>
+              <a:t>0.853 → Yes ✓</a:t>
             </a:r>
           </a:p>
         </p:txBody>
@@ -5771,7 +5764,7 @@
         </p:nvSpPr>
         <p:spPr>
           <a:xfrm>
-            <a:off x="8339327" y="3584448"/>
+            <a:off x="8339327" y="3621024"/>
             <a:ext cx="1353312" cy="256032"/>
           </a:xfrm>
           <a:prstGeom prst="rect">
@@ -5810,7 +5803,7 @@
         </p:nvSpPr>
         <p:spPr>
           <a:xfrm>
-            <a:off x="9710928" y="3584448"/>
+            <a:off x="9710928" y="3621024"/>
             <a:ext cx="1078992" cy="256032"/>
           </a:xfrm>
           <a:prstGeom prst="rect">
@@ -5849,7 +5842,7 @@
         </p:nvSpPr>
         <p:spPr>
           <a:xfrm>
-            <a:off x="10808208" y="3584448"/>
+            <a:off x="10808208" y="3621024"/>
             <a:ext cx="1005840" cy="256032"/>
           </a:xfrm>
           <a:prstGeom prst="rect">
@@ -5875,7 +5868,7 @@
                 </a:solidFill>
                 <a:latin typeface="Segoe UI"/>
               </a:rPr>
-              <a:t>0.948</a:t>
+              <a:t>0.930</a:t>
             </a:r>
           </a:p>
         </p:txBody>
@@ -5888,7 +5881,7 @@
         </p:nvSpPr>
         <p:spPr>
           <a:xfrm>
-            <a:off x="8339327" y="3858768"/>
+            <a:off x="8339327" y="3895344"/>
             <a:ext cx="1353312" cy="256032"/>
           </a:xfrm>
           <a:prstGeom prst="rect">
@@ -5927,7 +5920,7 @@
         </p:nvSpPr>
         <p:spPr>
           <a:xfrm>
-            <a:off x="9710928" y="3858768"/>
+            <a:off x="9710928" y="3895344"/>
             <a:ext cx="1078992" cy="256032"/>
           </a:xfrm>
           <a:prstGeom prst="rect">
@@ -5966,7 +5959,7 @@
         </p:nvSpPr>
         <p:spPr>
           <a:xfrm>
-            <a:off x="10808208" y="3858768"/>
+            <a:off x="10808208" y="3895344"/>
             <a:ext cx="1005840" cy="256032"/>
           </a:xfrm>
           <a:prstGeom prst="rect">
@@ -5992,7 +5985,7 @@
                 </a:solidFill>
                 <a:latin typeface="Segoe UI"/>
               </a:rPr>
-              <a:t>27 / 30</a:t>
+              <a:t>26 / 30</a:t>
             </a:r>
           </a:p>
         </p:txBody>
@@ -6005,8 +5998,8 @@
         </p:nvSpPr>
         <p:spPr>
           <a:xfrm>
-            <a:off x="411480" y="4617720"/>
-            <a:ext cx="11365992" cy="1170432"/>
+            <a:off x="411480" y="4736592"/>
+            <a:ext cx="11365992" cy="1051560"/>
           </a:xfrm>
           <a:prstGeom prst="roundRect">
             <a:avLst>
@@ -6051,8 +6044,8 @@
         </p:nvSpPr>
         <p:spPr>
           <a:xfrm>
-            <a:off x="685800" y="4745736"/>
-            <a:ext cx="10881360" cy="960120"/>
+            <a:off x="685800" y="4828032"/>
+            <a:ext cx="10881360" cy="914400"/>
           </a:xfrm>
           <a:prstGeom prst="rect">
             <a:avLst/>
@@ -6083,7 +6076,7 @@
           <a:p>
             <a:pPr algn="l">
               <a:spcAft>
-                <a:spcPts val="200"/>
+                <a:spcPts val="0"/>
               </a:spcAft>
             </a:pPr>
             <a:r>
@@ -6093,7 +6086,7 @@
                 </a:solidFill>
                 <a:latin typeface="Segoe UI"/>
               </a:rPr>
-              <a:t>Validated against real historical and current disaster events, the retrained model now correctly detects flood conditions in actual Sri Lankan scenarios (90% of events) while keeping non-flood predictions low — demonstrating accuracy, reliability and practical applicability as disaster decision support.</a:t>
+              <a:t>Validated on real historical and current disaster events, the retrained model now detects 87% of actual Sri Lankan flood events (AUC 0.930) while keeping 89% of non-flood control locations below threshold — demonstrating accuracy, reliability and practical applicability as disaster decision support.</a:t>
             </a:r>
           </a:p>
         </p:txBody>
@@ -6106,8 +6099,8 @@
         </p:nvSpPr>
         <p:spPr>
           <a:xfrm>
-            <a:off x="457200" y="5989320"/>
-            <a:ext cx="11247120" cy="640080"/>
+            <a:off x="457200" y="5925312"/>
+            <a:ext cx="11247120" cy="502920"/>
           </a:xfrm>
           <a:prstGeom prst="rect">
             <a:avLst/>
@@ -6126,13 +6119,13 @@
               </a:spcAft>
             </a:pPr>
             <a:r>
-              <a:rPr sz="950" b="0" i="1">
+              <a:rPr sz="900" b="0" i="1">
                 <a:solidFill>
                   <a:srgbClr val="6E6E73"/>
                 </a:solidFill>
                 <a:latin typeface="Segoe UI"/>
               </a:rPr>
-              <a:t>Honest limitation: without a live gauge reading, pure forecast skill remains weak (AUC ≈ 0.35) — the model is designed as decision support on top of live/entered DMC gauge readings.</a:t>
+              <a:t>Limitations (stated honestly): without a live gauge reading, pure forecast skill remains weak (AUC ≈ 0.33) — the model is decision support on top of live/entered DMC gauge readings. Controls are assumed non-flood (not verified); internal test has only 5 flood-days.</a:t>
             </a:r>
           </a:p>
         </p:txBody>
@@ -6145,7 +6138,7 @@
         </p:nvSpPr>
         <p:spPr>
           <a:xfrm>
-            <a:off x="457200" y="6446520"/>
+            <a:off x="457200" y="6419088"/>
             <a:ext cx="11247120" cy="274320"/>
           </a:xfrm>
           <a:prstGeom prst="rect">

</xml_diff>